<commit_message>
Add 3 new PPTX slides and regenerate all PDFs
Add PPTX slides matching existing branding for the 3 new outline entries:
- Module-07 slide: Day 1 Carryover Checklist (after Day 2 restart)
- Module-09 slide: Dataverse Readiness Checkpoint (before Lab 20)
- Module-12 slide: Evaluation Grader Types (before Lab 24)

Update PPTX slide counts across all documentation (95 → 98 total).
Regenerate all 10 workshop PDFs to reflect outline and count changes.

Co-authored-by: Copilot <223556219+Copilot@users.noreply.github.com>
</commit_message>
<xml_diff>
--- a/workshop/Copilot-Studio-Workshop-Slides/Module-07-Hiring-Architecture.pptx
+++ b/workshop/Copilot-Studio-Workshop-Slides/Module-07-Hiring-Architecture.pptx
@@ -6,6 +6,7 @@
   </p:sldMasterIdLst>
   <p:sldIdLst>
     <p:sldId id="256" r:id="rId2"/>
+    <p:sldId id="265" r:id="rId16"/>
     <p:sldId id="257" r:id="rId3"/>
     <p:sldId id="258" r:id="rId4"/>
     <p:sldId id="259" r:id="rId5"/>
@@ -552,6 +553,70 @@
 </p:notes>
 </file>
 
+<file path=ppt/notesSlides/notesSlide10.xml><?xml version="1.0" encoding="utf-8"?>
+<p:notes xmlns:a="http://schemas.openxmlformats.org/drawingml/2006/main" xmlns:r="http://schemas.openxmlformats.org/officeDocument/2006/relationships" xmlns:p="http://schemas.openxmlformats.org/presentationml/2006/main">
+  <p:cSld>
+    <p:spTree>
+      <p:nvGrpSpPr>
+        <p:cNvPr id="1" name=""/>
+        <p:cNvGrpSpPr/>
+        <p:nvPr/>
+      </p:nvGrpSpPr>
+      <p:grpSpPr>
+        <a:xfrm>
+          <a:off x="0" y="0"/>
+          <a:ext cx="0" cy="0"/>
+          <a:chOff x="0" y="0"/>
+          <a:chExt cx="0" cy="0"/>
+        </a:xfrm>
+      </p:grpSpPr>
+      <p:sp>
+        <p:nvSpPr>
+          <p:cNvPr id="2" name="Slide Image Placeholder 1"/>
+          <p:cNvSpPr>
+            <a:spLocks noGrp="1" noRot="1" noChangeAspect="1"/>
+          </p:cNvSpPr>
+          <p:nvPr>
+            <p:ph type="sldImg"/>
+          </p:nvPr>
+        </p:nvSpPr>
+        <p:spPr/>
+      </p:sp>
+      <p:sp>
+        <p:nvSpPr>
+          <p:cNvPr id="3" name="Notes Placeholder 2"/>
+          <p:cNvSpPr>
+            <a:spLocks noGrp="1"/>
+          </p:cNvSpPr>
+          <p:nvPr>
+            <p:ph type="body" idx="1"/>
+          </p:nvPr>
+        </p:nvSpPr>
+        <p:spPr/>
+        <p:txBody>
+          <a:bodyPr/>
+          <a:lstStyle/>
+          <a:p>
+            <a:r>
+              <a:rPr lang="en-US" dirty="0"/>
+              <a:t>Pause on this slide long enough for participants to self-check. Anyone who cannot confirm an item should raise it now rather than discovering the gap during Lab 14 or Lab 20. For facilitators: if several participants are missing a baseline item (for example, web search is still on or solution packaging was skipped), fix it as a group before proceeding. This two-minute checkpoint prevents the most common Day 2 compounding errors and gives late joiners a concrete catch-up reference.</a:t>
+            </a:r>
+          </a:p>
+        </p:txBody>
+      </p:sp>
+    </p:spTree>
+    <p:extLst>
+      <p:ext uri="{BB962C8B-B14F-4D97-AF65-F5344CB8AC3E}">
+        <p14:creationId xmlns:p14="http://schemas.microsoft.com/office/powerpoint/2010/main" val="1024086991"/>
+      </p:ext>
+    </p:extLst>
+  </p:cSld>
+  <p:clrMapOvr>
+    <a:masterClrMapping/>
+  </p:clrMapOvr>
+</p:notes>
+</file>
+
 <file path=ppt/notesSlides/notesSlide2.xml><?xml version="1.0" encoding="utf-8"?>
 <p:notes xmlns:a="http://schemas.openxmlformats.org/drawingml/2006/main" xmlns:r="http://schemas.openxmlformats.org/officeDocument/2006/relationships" xmlns:p="http://schemas.openxmlformats.org/presentationml/2006/main">
   <p:cSld>
@@ -2213,6 +2278,1187 @@
               <a:t>Day 2 starts here — Labs 13 through 24 + Optional Lab 25</a:t>
             </a:r>
             <a:endParaRPr lang="en-US" sz="1000" dirty="0"/>
+          </a:p>
+        </p:txBody>
+      </p:sp>
+    </p:spTree>
+  </p:cSld>
+  <p:clrMapOvr>
+    <a:masterClrMapping/>
+  </p:clrMapOvr>
+</p:sld>
+</file>
+
+<file path=ppt/slides/slide10.xml><?xml version="1.0" encoding="utf-8"?>
+<p:sld xmlns:a="http://schemas.openxmlformats.org/drawingml/2006/main" xmlns:r="http://schemas.openxmlformats.org/officeDocument/2006/relationships" xmlns:p="http://schemas.openxmlformats.org/presentationml/2006/main">
+  <p:cSld name="Day 1 Carryover Checklist">
+    <p:bg>
+      <p:bgPr>
+        <a:solidFill>
+          <a:srgbClr val="FFFFFF"/>
+        </a:solidFill>
+      </p:bgPr>
+    </p:bg>
+    <p:spTree>
+      <p:nvGrpSpPr>
+        <p:cNvPr id="1" name=""/>
+        <p:cNvGrpSpPr/>
+        <p:nvPr/>
+      </p:nvGrpSpPr>
+      <p:grpSpPr>
+        <a:xfrm>
+          <a:off x="0" y="0"/>
+          <a:ext cx="0" cy="0"/>
+          <a:chOff x="0" y="0"/>
+          <a:chExt cx="0" cy="0"/>
+        </a:xfrm>
+      </p:grpSpPr>
+      <p:sp>
+        <p:nvSpPr>
+          <p:cNvPr id="2" name="Shape 0"/>
+          <p:cNvSpPr/>
+          <p:nvPr/>
+        </p:nvSpPr>
+        <p:spPr>
+          <a:xfrm>
+            <a:off x="0" y="0"/>
+            <a:ext cx="9144000" cy="640080"/>
+          </a:xfrm>
+          <a:prstGeom prst="rect">
+            <a:avLst/>
+          </a:prstGeom>
+          <a:solidFill>
+            <a:srgbClr val="0078D4"/>
+          </a:solidFill>
+          <a:ln w="12700">
+            <a:solidFill>
+              <a:srgbClr val="0078D4"/>
+            </a:solidFill>
+            <a:prstDash val="solid"/>
+          </a:ln>
+        </p:spPr>
+      </p:sp>
+      <p:sp>
+        <p:nvSpPr>
+          <p:cNvPr id="3" name="Text 1"/>
+          <p:cNvSpPr/>
+          <p:nvPr/>
+        </p:nvSpPr>
+        <p:spPr>
+          <a:xfrm>
+            <a:off x="365760" y="0"/>
+            <a:ext cx="8412480" cy="640080"/>
+          </a:xfrm>
+          <a:prstGeom prst="rect">
+            <a:avLst/>
+          </a:prstGeom>
+          <a:noFill/>
+          <a:ln/>
+        </p:spPr>
+        <p:txBody>
+          <a:bodyPr wrap="square" rtlCol="0" anchor="ctr"/>
+          <a:lstStyle/>
+          <a:p>
+            <a:pPr indent="0" marL="0">
+              <a:buNone/>
+            </a:pPr>
+            <a:r>
+              <a:rPr lang="en-US" sz="900" spc="200" kern="0" dirty="0">
+                <a:solidFill>
+                  <a:srgbClr val="C5D8F0"/>
+                </a:solidFill>
+                <a:latin typeface="Segoe UI" pitchFamily="34" charset="0"/>
+                <a:ea typeface="Segoe UI" pitchFamily="34" charset="-122"/>
+                <a:cs typeface="Segoe UI" pitchFamily="34" charset="-120"/>
+              </a:rPr>
+              <a:t>MODULE 07  ·  HIRING ARCHITECTURE</a:t>
+            </a:r>
+            <a:endParaRPr lang="en-US" sz="900" dirty="0"/>
+          </a:p>
+        </p:txBody>
+      </p:sp>
+      <p:sp>
+        <p:nvSpPr>
+          <p:cNvPr id="4" name="Text 2"/>
+          <p:cNvSpPr/>
+          <p:nvPr/>
+        </p:nvSpPr>
+        <p:spPr>
+          <a:xfrm>
+            <a:off x="365760" y="749808"/>
+            <a:ext cx="8412480" cy="530352"/>
+          </a:xfrm>
+          <a:prstGeom prst="rect">
+            <a:avLst/>
+          </a:prstGeom>
+          <a:noFill/>
+          <a:ln/>
+        </p:spPr>
+        <p:txBody>
+          <a:bodyPr wrap="square" rtlCol="0" anchor="ctr"/>
+          <a:lstStyle/>
+          <a:p>
+            <a:pPr indent="0" marL="0">
+              <a:buNone/>
+            </a:pPr>
+            <a:r>
+              <a:rPr lang="en-US" sz="2800" b="1" dirty="0">
+                <a:solidFill>
+                  <a:srgbClr val="201F1E"/>
+                </a:solidFill>
+                <a:latin typeface="Segoe UI" pitchFamily="34" charset="0"/>
+                <a:ea typeface="Segoe UI" pitchFamily="34" charset="-122"/>
+                <a:cs typeface="Segoe UI" pitchFamily="34" charset="-120"/>
+              </a:rPr>
+              <a:t>Day 1 Carryover Checklist</a:t>
+            </a:r>
+            <a:endParaRPr lang="en-US" sz="2800" dirty="0"/>
+          </a:p>
+        </p:txBody>
+      </p:sp>
+      <p:sp>
+        <p:nvSpPr>
+          <p:cNvPr id="5" name="Text 3"/>
+          <p:cNvSpPr/>
+          <p:nvPr/>
+        </p:nvSpPr>
+        <p:spPr>
+          <a:xfrm>
+            <a:off x="365760" y="1325880"/>
+            <a:ext cx="8229600" cy="320040"/>
+          </a:xfrm>
+          <a:prstGeom prst="rect">
+            <a:avLst/>
+          </a:prstGeom>
+          <a:noFill/>
+          <a:ln/>
+        </p:spPr>
+        <p:txBody>
+          <a:bodyPr wrap="square" rtlCol="0" anchor="ctr"/>
+          <a:lstStyle/>
+          <a:p>
+            <a:pPr indent="0" marL="0">
+              <a:buNone/>
+            </a:pPr>
+            <a:r>
+              <a:rPr lang="en-US" sz="1200" dirty="0">
+                <a:solidFill>
+                  <a:srgbClr val="605E5C"/>
+                </a:solidFill>
+                <a:latin typeface="Segoe UI" pitchFamily="34" charset="0"/>
+                <a:ea typeface="Segoe UI" pitchFamily="34" charset="-122"/>
+                <a:cs typeface="Segoe UI" pitchFamily="34" charset="-120"/>
+              </a:rPr>
+              <a:t>Clear boundaries so each agent owns a focused responsibility — easier to test, support, and extend.</a:t>
+            </a:r>
+            <a:endParaRPr lang="en-US" sz="1200" dirty="0"/>
+          </a:p>
+        </p:txBody>
+      </p:sp>
+      <p:sp>
+        <p:nvSpPr>
+          <p:cNvPr id="6" name="Shape 4"/>
+          <p:cNvSpPr/>
+          <p:nvPr/>
+        </p:nvSpPr>
+        <p:spPr>
+          <a:xfrm>
+            <a:off x="256032" y="1783080"/>
+            <a:ext cx="2788920" cy="2377440"/>
+          </a:xfrm>
+          <a:prstGeom prst="rect">
+            <a:avLst/>
+          </a:prstGeom>
+          <a:solidFill>
+            <a:srgbClr val="F3F2F1"/>
+          </a:solidFill>
+          <a:ln w="12700">
+            <a:solidFill>
+              <a:srgbClr val="E1DFDD"/>
+            </a:solidFill>
+            <a:prstDash val="solid"/>
+          </a:ln>
+          <a:effectLst>
+            <a:outerShdw sx="100000" sy="100000" kx="0" ky="0" algn="bl" rotWithShape="0" blurRad="101600" dist="25400" dir="8100000">
+              <a:srgbClr val="000000">
+                <a:alpha val="10000"/>
+              </a:srgbClr>
+            </a:outerShdw>
+          </a:effectLst>
+        </p:spPr>
+      </p:sp>
+      <p:sp>
+        <p:nvSpPr>
+          <p:cNvPr id="7" name="Shape 5"/>
+          <p:cNvSpPr/>
+          <p:nvPr/>
+        </p:nvSpPr>
+        <p:spPr>
+          <a:xfrm>
+            <a:off x="256032" y="1783080"/>
+            <a:ext cx="2788920" cy="384048"/>
+          </a:xfrm>
+          <a:prstGeom prst="rect">
+            <a:avLst/>
+          </a:prstGeom>
+          <a:solidFill>
+            <a:srgbClr val="0078D4"/>
+          </a:solidFill>
+          <a:ln w="12700">
+            <a:solidFill>
+              <a:srgbClr val="0078D4"/>
+            </a:solidFill>
+            <a:prstDash val="solid"/>
+          </a:ln>
+        </p:spPr>
+      </p:sp>
+      <p:sp>
+        <p:nvSpPr>
+          <p:cNvPr id="8" name="Shape 6"/>
+          <p:cNvSpPr/>
+          <p:nvPr/>
+        </p:nvSpPr>
+        <p:spPr>
+          <a:xfrm>
+            <a:off x="347472" y="1874520"/>
+            <a:ext cx="731520" cy="201168"/>
+          </a:xfrm>
+          <a:prstGeom prst="rect">
+            <a:avLst/>
+          </a:prstGeom>
+          <a:solidFill>
+            <a:srgbClr val="FFFFFF"/>
+          </a:solidFill>
+          <a:ln w="12700">
+            <a:solidFill>
+              <a:srgbClr val="FFFFFF"/>
+            </a:solidFill>
+            <a:prstDash val="solid"/>
+          </a:ln>
+        </p:spPr>
+      </p:sp>
+      <p:sp>
+        <p:nvSpPr>
+          <p:cNvPr id="9" name="Text 7"/>
+          <p:cNvSpPr/>
+          <p:nvPr/>
+        </p:nvSpPr>
+        <p:spPr>
+          <a:xfrm>
+            <a:off x="347472" y="1874520"/>
+            <a:ext cx="731520" cy="201168"/>
+          </a:xfrm>
+          <a:prstGeom prst="rect">
+            <a:avLst/>
+          </a:prstGeom>
+          <a:noFill/>
+          <a:ln/>
+        </p:spPr>
+        <p:txBody>
+          <a:bodyPr wrap="square" lIns="0" tIns="0" rIns="0" bIns="0" rtlCol="0" anchor="ctr"/>
+          <a:lstStyle/>
+          <a:p>
+            <a:pPr algn="ctr" indent="0" marL="0">
+              <a:buNone/>
+            </a:pPr>
+            <a:r>
+              <a:rPr lang="en-US" sz="800" b="1" dirty="0">
+                <a:solidFill>
+                  <a:srgbClr val="0078D4"/>
+                </a:solidFill>
+                <a:latin typeface="Segoe UI" pitchFamily="34" charset="0"/>
+                <a:ea typeface="Segoe UI" pitchFamily="34" charset="-122"/>
+                <a:cs typeface="Segoe UI" pitchFamily="34" charset="-120"/>
+              </a:rPr>
+              <a:t>✓ Instructions aligned to tools</a:t>
+            </a:r>
+            <a:endParaRPr lang="en-US" sz="800" dirty="0"/>
+          </a:p>
+        </p:txBody>
+      </p:sp>
+      <p:sp>
+        <p:nvSpPr>
+          <p:cNvPr id="10" name="Text 8"/>
+          <p:cNvSpPr/>
+          <p:nvPr/>
+        </p:nvSpPr>
+        <p:spPr>
+          <a:xfrm>
+            <a:off x="1170432" y="1783080"/>
+            <a:ext cx="1783080" cy="384048"/>
+          </a:xfrm>
+          <a:prstGeom prst="rect">
+            <a:avLst/>
+          </a:prstGeom>
+          <a:noFill/>
+          <a:ln/>
+        </p:spPr>
+        <p:txBody>
+          <a:bodyPr wrap="square" rtlCol="0" anchor="ctr"/>
+          <a:lstStyle/>
+          <a:p>
+            <a:pPr indent="0" marL="0">
+              <a:buNone/>
+            </a:pPr>
+            <a:r>
+              <a:rPr lang="en-US" sz="1100" b="1" dirty="0">
+                <a:solidFill>
+                  <a:srgbClr val="FFFFFF"/>
+                </a:solidFill>
+                <a:latin typeface="Segoe UI" pitchFamily="34" charset="0"/>
+                <a:ea typeface="Segoe UI" pitchFamily="34" charset="-122"/>
+                <a:cs typeface="Segoe UI" pitchFamily="34" charset="-120"/>
+              </a:rPr>
+              <a:t>Hiring Agent</a:t>
+            </a:r>
+            <a:endParaRPr lang="en-US" sz="1100" dirty="0"/>
+          </a:p>
+        </p:txBody>
+      </p:sp>
+      <p:sp>
+        <p:nvSpPr>
+          <p:cNvPr id="11" name="Text 9"/>
+          <p:cNvSpPr/>
+          <p:nvPr/>
+        </p:nvSpPr>
+        <p:spPr>
+          <a:xfrm>
+            <a:off x="347472" y="2231136"/>
+            <a:ext cx="2624328" cy="274320"/>
+          </a:xfrm>
+          <a:prstGeom prst="rect">
+            <a:avLst/>
+          </a:prstGeom>
+          <a:noFill/>
+          <a:ln/>
+        </p:spPr>
+        <p:txBody>
+          <a:bodyPr wrap="square" rtlCol="0" anchor="ctr"/>
+          <a:lstStyle/>
+          <a:p>
+            <a:pPr indent="0" marL="0">
+              <a:buNone/>
+            </a:pPr>
+            <a:r>
+              <a:rPr lang="en-US" sz="950" b="1" dirty="0">
+                <a:solidFill>
+                  <a:srgbClr val="0078D4"/>
+                </a:solidFill>
+                <a:latin typeface="Segoe UI" pitchFamily="34" charset="0"/>
+                <a:ea typeface="Segoe UI" pitchFamily="34" charset="-122"/>
+                <a:cs typeface="Segoe UI" pitchFamily="34" charset="-120"/>
+              </a:rPr>
+              <a:t>Owns the recruiter conversation and routes to specialists</a:t>
+            </a:r>
+            <a:endParaRPr lang="en-US" sz="950" dirty="0"/>
+          </a:p>
+        </p:txBody>
+      </p:sp>
+      <p:sp>
+        <p:nvSpPr>
+          <p:cNvPr id="12" name="Text 10"/>
+          <p:cNvSpPr/>
+          <p:nvPr/>
+        </p:nvSpPr>
+        <p:spPr>
+          <a:xfrm>
+            <a:off x="347472" y="2542032"/>
+            <a:ext cx="2624328" cy="1536192"/>
+          </a:xfrm>
+          <a:prstGeom prst="rect">
+            <a:avLst/>
+          </a:prstGeom>
+          <a:noFill/>
+          <a:ln/>
+        </p:spPr>
+        <p:txBody>
+          <a:bodyPr wrap="square" rtlCol="0" anchor="ctr"/>
+          <a:lstStyle/>
+          <a:p>
+            <a:pPr marL="342900" indent="-342900">
+              <a:buSzPct val="100000"/>
+              <a:buChar char="•"/>
+            </a:pPr>
+            <a:r>
+              <a:rPr lang="en-US" sz="950" dirty="0">
+                <a:solidFill>
+                  <a:srgbClr val="201F1E"/>
+                </a:solidFill>
+                <a:latin typeface="Segoe UI" pitchFamily="34" charset="0"/>
+                <a:ea typeface="Segoe UI" pitchFamily="34" charset="-122"/>
+                <a:cs typeface="Segoe UI" pitchFamily="34" charset="-120"/>
+              </a:rPr>
+              <a:t>Delegates intake tasks to Application Intake Agent</a:t>
+            </a:r>
+            <a:endParaRPr lang="en-US" sz="950" dirty="0"/>
+          </a:p>
+          <a:p>
+            <a:pPr marL="342900" indent="-342900">
+              <a:buSzPct val="100000"/>
+              <a:buChar char="•"/>
+            </a:pPr>
+            <a:r>
+              <a:rPr lang="en-US" sz="950" dirty="0">
+                <a:solidFill>
+                  <a:srgbClr val="201F1E"/>
+                </a:solidFill>
+                <a:latin typeface="Segoe UI" pitchFamily="34" charset="0"/>
+                <a:ea typeface="Segoe UI" pitchFamily="34" charset="-122"/>
+                <a:cs typeface="Segoe UI" pitchFamily="34" charset="-120"/>
+              </a:rPr>
+              <a:t>Delegates interview prep to Interview Prep Agent</a:t>
+            </a:r>
+            <a:endParaRPr lang="en-US" sz="950" dirty="0"/>
+          </a:p>
+          <a:p>
+            <a:pPr marL="342900" indent="-342900">
+              <a:buSzPct val="100000"/>
+              <a:buChar char="•"/>
+            </a:pPr>
+            <a:r>
+              <a:rPr lang="en-US" sz="950" dirty="0">
+                <a:solidFill>
+                  <a:srgbClr val="201F1E"/>
+                </a:solidFill>
+                <a:latin typeface="Segoe UI" pitchFamily="34" charset="0"/>
+                <a:ea typeface="Segoe UI" pitchFamily="34" charset="-122"/>
+                <a:cs typeface="Segoe UI" pitchFamily="34" charset="-120"/>
+              </a:rPr>
+              <a:t>Maintains conversation context across all specialist calls</a:t>
+            </a:r>
+            <a:endParaRPr lang="en-US" sz="950" dirty="0"/>
+          </a:p>
+          <a:p>
+            <a:pPr marL="342900" indent="-342900">
+              <a:buSzPct val="100000"/>
+              <a:buChar char="•"/>
+            </a:pPr>
+            <a:r>
+              <a:rPr lang="en-US" sz="950" dirty="0">
+                <a:solidFill>
+                  <a:srgbClr val="201F1E"/>
+                </a:solidFill>
+                <a:latin typeface="Segoe UI" pitchFamily="34" charset="0"/>
+                <a:ea typeface="Segoe UI" pitchFamily="34" charset="-122"/>
+                <a:cs typeface="Segoe UI" pitchFamily="34" charset="-120"/>
+              </a:rPr>
+              <a:t>Uses generative AI orchestration for routing decisions</a:t>
+            </a:r>
+            <a:endParaRPr lang="en-US" sz="950" dirty="0"/>
+          </a:p>
+        </p:txBody>
+      </p:sp>
+      <p:sp>
+        <p:nvSpPr>
+          <p:cNvPr id="13" name="Shape 11"/>
+          <p:cNvSpPr/>
+          <p:nvPr/>
+        </p:nvSpPr>
+        <p:spPr>
+          <a:xfrm>
+            <a:off x="3163824" y="1783080"/>
+            <a:ext cx="2788920" cy="2377440"/>
+          </a:xfrm>
+          <a:prstGeom prst="rect">
+            <a:avLst/>
+          </a:prstGeom>
+          <a:solidFill>
+            <a:srgbClr val="F3F2F1"/>
+          </a:solidFill>
+          <a:ln w="12700">
+            <a:solidFill>
+              <a:srgbClr val="E1DFDD"/>
+            </a:solidFill>
+            <a:prstDash val="solid"/>
+          </a:ln>
+          <a:effectLst>
+            <a:outerShdw sx="100000" sy="100000" kx="0" ky="0" algn="bl" rotWithShape="0" blurRad="101600" dist="25400" dir="8100000">
+              <a:srgbClr val="000000">
+                <a:alpha val="10000"/>
+              </a:srgbClr>
+            </a:outerShdw>
+          </a:effectLst>
+        </p:spPr>
+      </p:sp>
+      <p:sp>
+        <p:nvSpPr>
+          <p:cNvPr id="14" name="Shape 12"/>
+          <p:cNvSpPr/>
+          <p:nvPr/>
+        </p:nvSpPr>
+        <p:spPr>
+          <a:xfrm>
+            <a:off x="3163824" y="1783080"/>
+            <a:ext cx="2788920" cy="384048"/>
+          </a:xfrm>
+          <a:prstGeom prst="rect">
+            <a:avLst/>
+          </a:prstGeom>
+          <a:solidFill>
+            <a:srgbClr val="00B294"/>
+          </a:solidFill>
+          <a:ln w="12700">
+            <a:solidFill>
+              <a:srgbClr val="00B294"/>
+            </a:solidFill>
+            <a:prstDash val="solid"/>
+          </a:ln>
+        </p:spPr>
+      </p:sp>
+      <p:sp>
+        <p:nvSpPr>
+          <p:cNvPr id="15" name="Shape 13"/>
+          <p:cNvSpPr/>
+          <p:nvPr/>
+        </p:nvSpPr>
+        <p:spPr>
+          <a:xfrm>
+            <a:off x="3255264" y="1874520"/>
+            <a:ext cx="731520" cy="201168"/>
+          </a:xfrm>
+          <a:prstGeom prst="rect">
+            <a:avLst/>
+          </a:prstGeom>
+          <a:solidFill>
+            <a:srgbClr val="FFFFFF"/>
+          </a:solidFill>
+          <a:ln w="12700">
+            <a:solidFill>
+              <a:srgbClr val="FFFFFF"/>
+            </a:solidFill>
+            <a:prstDash val="solid"/>
+          </a:ln>
+        </p:spPr>
+      </p:sp>
+      <p:sp>
+        <p:nvSpPr>
+          <p:cNvPr id="16" name="Text 14"/>
+          <p:cNvSpPr/>
+          <p:nvPr/>
+        </p:nvSpPr>
+        <p:spPr>
+          <a:xfrm>
+            <a:off x="3255264" y="1874520"/>
+            <a:ext cx="731520" cy="201168"/>
+          </a:xfrm>
+          <a:prstGeom prst="rect">
+            <a:avLst/>
+          </a:prstGeom>
+          <a:noFill/>
+          <a:ln/>
+        </p:spPr>
+        <p:txBody>
+          <a:bodyPr wrap="square" lIns="0" tIns="0" rIns="0" bIns="0" rtlCol="0" anchor="ctr"/>
+          <a:lstStyle/>
+          <a:p>
+            <a:pPr algn="ctr" indent="0" marL="0">
+              <a:buNone/>
+            </a:pPr>
+            <a:r>
+              <a:rPr lang="en-US" sz="800" b="1" dirty="0">
+                <a:solidFill>
+                  <a:srgbClr val="00B294"/>
+                </a:solidFill>
+                <a:latin typeface="Segoe UI" pitchFamily="34" charset="0"/>
+                <a:ea typeface="Segoe UI" pitchFamily="34" charset="-122"/>
+                <a:cs typeface="Segoe UI" pitchFamily="34" charset="-120"/>
+              </a:rPr>
+              <a:t>Child Agent</a:t>
+            </a:r>
+            <a:endParaRPr lang="en-US" sz="800" dirty="0"/>
+          </a:p>
+        </p:txBody>
+      </p:sp>
+      <p:sp>
+        <p:nvSpPr>
+          <p:cNvPr id="17" name="Text 15"/>
+          <p:cNvSpPr/>
+          <p:nvPr/>
+        </p:nvSpPr>
+        <p:spPr>
+          <a:xfrm>
+            <a:off x="4078224" y="1783080"/>
+            <a:ext cx="1783080" cy="384048"/>
+          </a:xfrm>
+          <a:prstGeom prst="rect">
+            <a:avLst/>
+          </a:prstGeom>
+          <a:noFill/>
+          <a:ln/>
+        </p:spPr>
+        <p:txBody>
+          <a:bodyPr wrap="square" rtlCol="0" anchor="ctr"/>
+          <a:lstStyle/>
+          <a:p>
+            <a:pPr indent="0" marL="0">
+              <a:buNone/>
+            </a:pPr>
+            <a:r>
+              <a:rPr lang="en-US" sz="1100" b="1" dirty="0">
+                <a:solidFill>
+                  <a:srgbClr val="FFFFFF"/>
+                </a:solidFill>
+                <a:latin typeface="Segoe UI" pitchFamily="34" charset="0"/>
+                <a:ea typeface="Segoe UI" pitchFamily="34" charset="-122"/>
+                <a:cs typeface="Segoe UI" pitchFamily="34" charset="-120"/>
+              </a:rPr>
+              <a:t>Application Intake Agent</a:t>
+            </a:r>
+            <a:endParaRPr lang="en-US" sz="1100" dirty="0"/>
+          </a:p>
+        </p:txBody>
+      </p:sp>
+      <p:sp>
+        <p:nvSpPr>
+          <p:cNvPr id="18" name="Text 16"/>
+          <p:cNvSpPr/>
+          <p:nvPr/>
+        </p:nvSpPr>
+        <p:spPr>
+          <a:xfrm>
+            <a:off x="3255264" y="2231136"/>
+            <a:ext cx="2624328" cy="274320"/>
+          </a:xfrm>
+          <a:prstGeom prst="rect">
+            <a:avLst/>
+          </a:prstGeom>
+          <a:noFill/>
+          <a:ln/>
+        </p:spPr>
+        <p:txBody>
+          <a:bodyPr wrap="square" rtlCol="0" anchor="ctr"/>
+          <a:lstStyle/>
+          <a:p>
+            <a:pPr indent="0" marL="0">
+              <a:buNone/>
+            </a:pPr>
+            <a:r>
+              <a:rPr lang="en-US" sz="950" b="1" dirty="0">
+                <a:solidFill>
+                  <a:srgbClr val="00B294"/>
+                </a:solidFill>
+                <a:latin typeface="Segoe UI" pitchFamily="34" charset="0"/>
+                <a:ea typeface="Segoe UI" pitchFamily="34" charset="-122"/>
+                <a:cs typeface="Segoe UI" pitchFamily="34" charset="-120"/>
+              </a:rPr>
+              <a:t>Handles new resumes and candidate data collection</a:t>
+            </a:r>
+            <a:endParaRPr lang="en-US" sz="950" dirty="0"/>
+          </a:p>
+        </p:txBody>
+      </p:sp>
+      <p:sp>
+        <p:nvSpPr>
+          <p:cNvPr id="19" name="Text 17"/>
+          <p:cNvSpPr/>
+          <p:nvPr/>
+        </p:nvSpPr>
+        <p:spPr>
+          <a:xfrm>
+            <a:off x="3255264" y="2542032"/>
+            <a:ext cx="2624328" cy="1536192"/>
+          </a:xfrm>
+          <a:prstGeom prst="rect">
+            <a:avLst/>
+          </a:prstGeom>
+          <a:noFill/>
+          <a:ln/>
+        </p:spPr>
+        <p:txBody>
+          <a:bodyPr wrap="square" rtlCol="0" anchor="ctr"/>
+          <a:lstStyle/>
+          <a:p>
+            <a:pPr marL="342900" indent="-342900">
+              <a:buSzPct val="100000"/>
+              <a:buChar char="•"/>
+            </a:pPr>
+            <a:r>
+              <a:rPr lang="en-US" sz="950" dirty="0">
+                <a:solidFill>
+                  <a:srgbClr val="201F1E"/>
+                </a:solidFill>
+                <a:latin typeface="Segoe UI" pitchFamily="34" charset="0"/>
+                <a:ea typeface="Segoe UI" pitchFamily="34" charset="-122"/>
+                <a:cs typeface="Segoe UI" pitchFamily="34" charset="-120"/>
+              </a:rPr>
+              <a:t>Receives delegated intake tasks from the orchestrator</a:t>
+            </a:r>
+            <a:endParaRPr lang="en-US" sz="950" dirty="0"/>
+          </a:p>
+          <a:p>
+            <a:pPr marL="342900" indent="-342900">
+              <a:buSzPct val="100000"/>
+              <a:buChar char="•"/>
+            </a:pPr>
+            <a:r>
+              <a:rPr lang="en-US" sz="950" dirty="0">
+                <a:solidFill>
+                  <a:srgbClr val="201F1E"/>
+                </a:solidFill>
+                <a:latin typeface="Segoe UI" pitchFamily="34" charset="0"/>
+                <a:ea typeface="Segoe UI" pitchFamily="34" charset="-122"/>
+                <a:cs typeface="Segoe UI" pitchFamily="34" charset="-120"/>
+              </a:rPr>
+              <a:t>Collects missing candidate details and prepares summaries</a:t>
+            </a:r>
+            <a:endParaRPr lang="en-US" sz="950" dirty="0"/>
+          </a:p>
+          <a:p>
+            <a:pPr marL="342900" indent="-342900">
+              <a:buSzPct val="100000"/>
+              <a:buChar char="•"/>
+            </a:pPr>
+            <a:r>
+              <a:rPr lang="en-US" sz="950" dirty="0">
+                <a:solidFill>
+                  <a:srgbClr val="201F1E"/>
+                </a:solidFill>
+                <a:latin typeface="Segoe UI" pitchFamily="34" charset="0"/>
+                <a:ea typeface="Segoe UI" pitchFamily="34" charset="-122"/>
+                <a:cs typeface="Segoe UI" pitchFamily="34" charset="-120"/>
+              </a:rPr>
+              <a:t>Stores candidate and application records to Dataverse</a:t>
+            </a:r>
+            <a:endParaRPr lang="en-US" sz="950" dirty="0"/>
+          </a:p>
+          <a:p>
+            <a:pPr marL="342900" indent="-342900">
+              <a:buSzPct val="100000"/>
+              <a:buChar char="•"/>
+            </a:pPr>
+            <a:r>
+              <a:rPr lang="en-US" sz="950" dirty="0">
+                <a:solidFill>
+                  <a:srgbClr val="201F1E"/>
+                </a:solidFill>
+                <a:latin typeface="Segoe UI" pitchFamily="34" charset="0"/>
+                <a:ea typeface="Segoe UI" pitchFamily="34" charset="-122"/>
+                <a:cs typeface="Segoe UI" pitchFamily="34" charset="-120"/>
+              </a:rPr>
+              <a:t>Stays focused on intake — routes interview requests back</a:t>
+            </a:r>
+            <a:endParaRPr lang="en-US" sz="950" dirty="0"/>
+          </a:p>
+        </p:txBody>
+      </p:sp>
+      <p:sp>
+        <p:nvSpPr>
+          <p:cNvPr id="20" name="Shape 18"/>
+          <p:cNvSpPr/>
+          <p:nvPr/>
+        </p:nvSpPr>
+        <p:spPr>
+          <a:xfrm>
+            <a:off x="6071616" y="1783080"/>
+            <a:ext cx="2788920" cy="2377440"/>
+          </a:xfrm>
+          <a:prstGeom prst="rect">
+            <a:avLst/>
+          </a:prstGeom>
+          <a:solidFill>
+            <a:srgbClr val="F3F2F1"/>
+          </a:solidFill>
+          <a:ln w="12700">
+            <a:solidFill>
+              <a:srgbClr val="E1DFDD"/>
+            </a:solidFill>
+            <a:prstDash val="solid"/>
+          </a:ln>
+          <a:effectLst>
+            <a:outerShdw sx="100000" sy="100000" kx="0" ky="0" algn="bl" rotWithShape="0" blurRad="101600" dist="25400" dir="8100000">
+              <a:srgbClr val="000000">
+                <a:alpha val="10000"/>
+              </a:srgbClr>
+            </a:outerShdw>
+          </a:effectLst>
+        </p:spPr>
+      </p:sp>
+      <p:sp>
+        <p:nvSpPr>
+          <p:cNvPr id="21" name="Shape 19"/>
+          <p:cNvSpPr/>
+          <p:nvPr/>
+        </p:nvSpPr>
+        <p:spPr>
+          <a:xfrm>
+            <a:off x="6071616" y="1783080"/>
+            <a:ext cx="2788920" cy="384048"/>
+          </a:xfrm>
+          <a:prstGeom prst="rect">
+            <a:avLst/>
+          </a:prstGeom>
+          <a:solidFill>
+            <a:srgbClr val="5C2D91"/>
+          </a:solidFill>
+          <a:ln w="12700">
+            <a:solidFill>
+              <a:srgbClr val="5C2D91"/>
+            </a:solidFill>
+            <a:prstDash val="solid"/>
+          </a:ln>
+        </p:spPr>
+      </p:sp>
+      <p:sp>
+        <p:nvSpPr>
+          <p:cNvPr id="22" name="Shape 20"/>
+          <p:cNvSpPr/>
+          <p:nvPr/>
+        </p:nvSpPr>
+        <p:spPr>
+          <a:xfrm>
+            <a:off x="6163056" y="1874520"/>
+            <a:ext cx="731520" cy="201168"/>
+          </a:xfrm>
+          <a:prstGeom prst="rect">
+            <a:avLst/>
+          </a:prstGeom>
+          <a:solidFill>
+            <a:srgbClr val="FFFFFF"/>
+          </a:solidFill>
+          <a:ln w="12700">
+            <a:solidFill>
+              <a:srgbClr val="FFFFFF"/>
+            </a:solidFill>
+            <a:prstDash val="solid"/>
+          </a:ln>
+        </p:spPr>
+      </p:sp>
+      <p:sp>
+        <p:nvSpPr>
+          <p:cNvPr id="23" name="Text 21"/>
+          <p:cNvSpPr/>
+          <p:nvPr/>
+        </p:nvSpPr>
+        <p:spPr>
+          <a:xfrm>
+            <a:off x="6163056" y="1874520"/>
+            <a:ext cx="731520" cy="201168"/>
+          </a:xfrm>
+          <a:prstGeom prst="rect">
+            <a:avLst/>
+          </a:prstGeom>
+          <a:noFill/>
+          <a:ln/>
+        </p:spPr>
+        <p:txBody>
+          <a:bodyPr wrap="square" lIns="0" tIns="0" rIns="0" bIns="0" rtlCol="0" anchor="ctr"/>
+          <a:lstStyle/>
+          <a:p>
+            <a:pPr algn="ctr" indent="0" marL="0">
+              <a:buNone/>
+            </a:pPr>
+            <a:r>
+              <a:rPr lang="en-US" sz="800" b="1" dirty="0">
+                <a:solidFill>
+                  <a:srgbClr val="5C2D91"/>
+                </a:solidFill>
+                <a:latin typeface="Segoe UI" pitchFamily="34" charset="0"/>
+                <a:ea typeface="Segoe UI" pitchFamily="34" charset="-122"/>
+                <a:cs typeface="Segoe UI" pitchFamily="34" charset="-120"/>
+              </a:rPr>
+              <a:t>Connected Agent</a:t>
+            </a:r>
+            <a:endParaRPr lang="en-US" sz="800" dirty="0"/>
+          </a:p>
+        </p:txBody>
+      </p:sp>
+      <p:sp>
+        <p:nvSpPr>
+          <p:cNvPr id="24" name="Text 22"/>
+          <p:cNvSpPr/>
+          <p:nvPr/>
+        </p:nvSpPr>
+        <p:spPr>
+          <a:xfrm>
+            <a:off x="6986016" y="1783080"/>
+            <a:ext cx="1783080" cy="384048"/>
+          </a:xfrm>
+          <a:prstGeom prst="rect">
+            <a:avLst/>
+          </a:prstGeom>
+          <a:noFill/>
+          <a:ln/>
+        </p:spPr>
+        <p:txBody>
+          <a:bodyPr wrap="square" rtlCol="0" anchor="ctr"/>
+          <a:lstStyle/>
+          <a:p>
+            <a:pPr indent="0" marL="0">
+              <a:buNone/>
+            </a:pPr>
+            <a:r>
+              <a:rPr lang="en-US" sz="1100" b="1" dirty="0">
+                <a:solidFill>
+                  <a:srgbClr val="FFFFFF"/>
+                </a:solidFill>
+                <a:latin typeface="Segoe UI" pitchFamily="34" charset="0"/>
+                <a:ea typeface="Segoe UI" pitchFamily="34" charset="-122"/>
+                <a:cs typeface="Segoe UI" pitchFamily="34" charset="-120"/>
+              </a:rPr>
+              <a:t>Interview Prep Agent</a:t>
+            </a:r>
+            <a:endParaRPr lang="en-US" sz="1100" dirty="0"/>
+          </a:p>
+        </p:txBody>
+      </p:sp>
+      <p:sp>
+        <p:nvSpPr>
+          <p:cNvPr id="25" name="Text 23"/>
+          <p:cNvSpPr/>
+          <p:nvPr/>
+        </p:nvSpPr>
+        <p:spPr>
+          <a:xfrm>
+            <a:off x="6163056" y="2231136"/>
+            <a:ext cx="2624328" cy="274320"/>
+          </a:xfrm>
+          <a:prstGeom prst="rect">
+            <a:avLst/>
+          </a:prstGeom>
+          <a:noFill/>
+          <a:ln/>
+        </p:spPr>
+        <p:txBody>
+          <a:bodyPr wrap="square" rtlCol="0" anchor="ctr"/>
+          <a:lstStyle/>
+          <a:p>
+            <a:pPr indent="0" marL="0">
+              <a:buNone/>
+            </a:pPr>
+            <a:r>
+              <a:rPr lang="en-US" sz="950" b="1" dirty="0">
+                <a:solidFill>
+                  <a:srgbClr val="5C2D91"/>
+                </a:solidFill>
+                <a:latin typeface="Segoe UI" pitchFamily="34" charset="0"/>
+                <a:ea typeface="Segoe UI" pitchFamily="34" charset="-122"/>
+                <a:cs typeface="Segoe UI" pitchFamily="34" charset="-120"/>
+              </a:rPr>
+              <a:t>Creates interview guides, questions, and evaluation support</a:t>
+            </a:r>
+            <a:endParaRPr lang="en-US" sz="950" dirty="0"/>
+          </a:p>
+        </p:txBody>
+      </p:sp>
+      <p:sp>
+        <p:nvSpPr>
+          <p:cNvPr id="26" name="Text 24"/>
+          <p:cNvSpPr/>
+          <p:nvPr/>
+        </p:nvSpPr>
+        <p:spPr>
+          <a:xfrm>
+            <a:off x="6163056" y="2542032"/>
+            <a:ext cx="2624328" cy="1536192"/>
+          </a:xfrm>
+          <a:prstGeom prst="rect">
+            <a:avLst/>
+          </a:prstGeom>
+          <a:noFill/>
+          <a:ln/>
+        </p:spPr>
+        <p:txBody>
+          <a:bodyPr wrap="square" rtlCol="0" anchor="ctr"/>
+          <a:lstStyle/>
+          <a:p>
+            <a:pPr marL="342900" indent="-342900">
+              <a:buSzPct val="100000"/>
+              <a:buChar char="•"/>
+            </a:pPr>
+            <a:r>
+              <a:rPr lang="en-US" sz="950" dirty="0">
+                <a:solidFill>
+                  <a:srgbClr val="201F1E"/>
+                </a:solidFill>
+                <a:latin typeface="Segoe UI" pitchFamily="34" charset="0"/>
+                <a:ea typeface="Segoe UI" pitchFamily="34" charset="-122"/>
+                <a:cs typeface="Segoe UI" pitchFamily="34" charset="-120"/>
+              </a:rPr>
+              <a:t>Discoverable by other agents in the same environment</a:t>
+            </a:r>
+            <a:endParaRPr lang="en-US" sz="950" dirty="0"/>
+          </a:p>
+          <a:p>
+            <a:pPr marL="342900" indent="-342900">
+              <a:buSzPct val="100000"/>
+              <a:buChar char="•"/>
+            </a:pPr>
+            <a:r>
+              <a:rPr lang="en-US" sz="950" dirty="0">
+                <a:solidFill>
+                  <a:srgbClr val="201F1E"/>
+                </a:solidFill>
+                <a:latin typeface="Segoe UI" pitchFamily="34" charset="0"/>
+                <a:ea typeface="Segoe UI" pitchFamily="34" charset="-122"/>
+                <a:cs typeface="Segoe UI" pitchFamily="34" charset="-120"/>
+              </a:rPr>
+              <a:t>Grounded in Dataverse Job Role and Evaluation Criteria tables</a:t>
+            </a:r>
+            <a:endParaRPr lang="en-US" sz="950" dirty="0"/>
+          </a:p>
+          <a:p>
+            <a:pPr marL="342900" indent="-342900">
+              <a:buSzPct val="100000"/>
+              <a:buChar char="•"/>
+            </a:pPr>
+            <a:r>
+              <a:rPr lang="en-US" sz="950" dirty="0">
+                <a:solidFill>
+                  <a:srgbClr val="201F1E"/>
+                </a:solidFill>
+                <a:latin typeface="Segoe UI" pitchFamily="34" charset="0"/>
+                <a:ea typeface="Segoe UI" pitchFamily="34" charset="-122"/>
+                <a:cs typeface="Segoe UI" pitchFamily="34" charset="-120"/>
+              </a:rPr>
+              <a:t>Produces structured interview rubrics and question sets</a:t>
+            </a:r>
+            <a:endParaRPr lang="en-US" sz="950" dirty="0"/>
+          </a:p>
+          <a:p>
+            <a:pPr marL="342900" indent="-342900">
+              <a:buSzPct val="100000"/>
+              <a:buChar char="•"/>
+            </a:pPr>
+            <a:r>
+              <a:rPr lang="en-US" sz="950" dirty="0">
+                <a:solidFill>
+                  <a:srgbClr val="201F1E"/>
+                </a:solidFill>
+                <a:latin typeface="Segoe UI" pitchFamily="34" charset="0"/>
+                <a:ea typeface="Segoe UI" pitchFamily="34" charset="-122"/>
+                <a:cs typeface="Segoe UI" pitchFamily="34" charset="-120"/>
+              </a:rPr>
+              <a:t>Configured with 'Allow connections' on for orchestrator discovery</a:t>
+            </a:r>
+            <a:endParaRPr lang="en-US" sz="950" dirty="0"/>
+          </a:p>
+        </p:txBody>
+      </p:sp>
+      <p:sp>
+        <p:nvSpPr>
+          <p:cNvPr id="27" name="Shape 25"/>
+          <p:cNvSpPr/>
+          <p:nvPr/>
+        </p:nvSpPr>
+        <p:spPr>
+          <a:xfrm>
+            <a:off x="256032" y="4251960"/>
+            <a:ext cx="8631936" cy="347472"/>
+          </a:xfrm>
+          <a:prstGeom prst="rect">
+            <a:avLst/>
+          </a:prstGeom>
+          <a:solidFill>
+            <a:srgbClr val="D47900"/>
+          </a:solidFill>
+          <a:ln w="12700">
+            <a:solidFill>
+              <a:srgbClr val="D47900"/>
+            </a:solidFill>
+            <a:prstDash val="solid"/>
+          </a:ln>
+        </p:spPr>
+      </p:sp>
+      <p:sp>
+        <p:nvSpPr>
+          <p:cNvPr id="28" name="Text 26"/>
+          <p:cNvSpPr/>
+          <p:nvPr/>
+        </p:nvSpPr>
+        <p:spPr>
+          <a:xfrm>
+            <a:off x="320040" y="4251960"/>
+            <a:ext cx="8503920" cy="347472"/>
+          </a:xfrm>
+          <a:prstGeom prst="rect">
+            <a:avLst/>
+          </a:prstGeom>
+          <a:noFill/>
+          <a:ln/>
+        </p:spPr>
+        <p:txBody>
+          <a:bodyPr wrap="square" rtlCol="0" anchor="ctr"/>
+          <a:lstStyle/>
+          <a:p>
+            <a:pPr indent="0" marL="0">
+              <a:buNone/>
+            </a:pPr>
+            <a:r>
+              <a:rPr lang="en-US" sz="1050" b="1" dirty="0">
+                <a:solidFill>
+                  <a:srgbClr val="FFFFFF"/>
+                </a:solidFill>
+                <a:latin typeface="Segoe UI" pitchFamily="34" charset="0"/>
+                <a:ea typeface="Segoe UI" pitchFamily="34" charset="-122"/>
+                <a:cs typeface="Segoe UI" pitchFamily="34" charset="-120"/>
+              </a:rPr>
+              <a:t>Shared Data  ·  Dataverse: Candidate, Resume, Job Application, Job Role, Evaluation Criteria</a:t>
+            </a:r>
+            <a:endParaRPr lang="en-US" sz="1050" dirty="0"/>
+          </a:p>
+        </p:txBody>
+      </p:sp>
+      <p:sp>
+        <p:nvSpPr>
+          <p:cNvPr id="29" name="Shape 27"/>
+          <p:cNvSpPr/>
+          <p:nvPr/>
+        </p:nvSpPr>
+        <p:spPr>
+          <a:xfrm>
+            <a:off x="256032" y="4663440"/>
+            <a:ext cx="8631936" cy="320040"/>
+          </a:xfrm>
+          <a:prstGeom prst="rect">
+            <a:avLst/>
+          </a:prstGeom>
+          <a:solidFill>
+            <a:srgbClr val="EFF6FC"/>
+          </a:solidFill>
+          <a:ln w="12700">
+            <a:solidFill>
+              <a:srgbClr val="C7E0F4"/>
+            </a:solidFill>
+            <a:prstDash val="solid"/>
+          </a:ln>
+        </p:spPr>
+      </p:sp>
+      <p:sp>
+        <p:nvSpPr>
+          <p:cNvPr id="30" name="Text 28"/>
+          <p:cNvSpPr/>
+          <p:nvPr/>
+        </p:nvSpPr>
+        <p:spPr>
+          <a:xfrm>
+            <a:off x="402336" y="4663440"/>
+            <a:ext cx="8485632" cy="320040"/>
+          </a:xfrm>
+          <a:prstGeom prst="rect">
+            <a:avLst/>
+          </a:prstGeom>
+          <a:noFill/>
+          <a:ln/>
+        </p:spPr>
+        <p:txBody>
+          <a:bodyPr wrap="square" rtlCol="0" anchor="ctr"/>
+          <a:lstStyle/>
+          <a:p>
+            <a:pPr indent="0" marL="0">
+              <a:buNone/>
+            </a:pPr>
+            <a:r>
+              <a:rPr lang="en-US" sz="1050" dirty="0">
+                <a:solidFill>
+                  <a:srgbClr val="0078D4"/>
+                </a:solidFill>
+                <a:latin typeface="Segoe UI" pitchFamily="34" charset="0"/>
+                <a:ea typeface="Segoe UI" pitchFamily="34" charset="-122"/>
+                <a:cs typeface="Segoe UI" pitchFamily="34" charset="-120"/>
+              </a:rPr>
+              <a:t>The Self-check is the operating view for debugging handoffs — confirm each agent call is visible before moving on.</a:t>
+            </a:r>
+            <a:endParaRPr lang="en-US" sz="1050" dirty="0"/>
           </a:p>
         </p:txBody>
       </p:sp>

</xml_diff>